<commit_message>
Añade imágenes extraídas del PDF (logo, caricatura y galería de obras del film)
</commit_message>
<xml_diff>
--- a/Defensa_TFG_Las_estatuas_tambien_mueren.pptx
+++ b/Defensa_TFG_Las_estatuas_tambien_mueren.pptx
@@ -3244,14 +3244,82 @@
       </p:sp>
       <p:sp>
         <p:nvSpPr>
-          <p:cNvPr id="5" name="TextBox 4"/>
+          <p:cNvPr id="5" name="Rounded Rectangle 4"/>
+          <p:cNvSpPr/>
+          <p:nvPr/>
+        </p:nvSpPr>
+        <p:spPr>
+          <a:xfrm>
+            <a:off x="10058400" y="548640"/>
+            <a:ext cx="1554480" cy="1554480"/>
+          </a:xfrm>
+          <a:prstGeom prst="roundRect">
+            <a:avLst/>
+          </a:prstGeom>
+          <a:solidFill>
+            <a:srgbClr val="FFFFFF"/>
+          </a:solidFill>
+          <a:ln>
+            <a:noFill/>
+          </a:ln>
+          <a:effectLst/>
+        </p:spPr>
+        <p:style>
+          <a:lnRef idx="1">
+            <a:schemeClr val="accent1"/>
+          </a:lnRef>
+          <a:fillRef idx="3">
+            <a:schemeClr val="accent1"/>
+          </a:fillRef>
+          <a:effectRef idx="2">
+            <a:schemeClr val="accent1"/>
+          </a:effectRef>
+          <a:fontRef idx="minor">
+            <a:schemeClr val="lt1"/>
+          </a:fontRef>
+        </p:style>
+        <p:txBody>
+          <a:bodyPr rtlCol="0" anchor="ctr"/>
+          <a:lstStyle/>
+          <a:p>
+            <a:pPr algn="ctr"/>
+          </a:p>
+        </p:txBody>
+      </p:sp>
+      <p:pic>
+        <p:nvPicPr>
+          <p:cNvPr id="6" name="Picture 5" descr="logo_umu.jpeg"/>
+          <p:cNvPicPr>
+            <a:picLocks noChangeAspect="1"/>
+          </p:cNvPicPr>
+          <p:nvPr/>
+        </p:nvPicPr>
+        <p:blipFill>
+          <a:blip r:embed="rId2"/>
+          <a:stretch>
+            <a:fillRect/>
+          </a:stretch>
+        </p:blipFill>
+        <p:spPr>
+          <a:xfrm>
+            <a:off x="10168128" y="658368"/>
+            <a:ext cx="1335024" cy="1335024"/>
+          </a:xfrm>
+          <a:prstGeom prst="rect">
+            <a:avLst/>
+          </a:prstGeom>
+        </p:spPr>
+      </p:pic>
+      <p:sp>
+        <p:nvSpPr>
+          <p:cNvPr id="7" name="TextBox 6"/>
           <p:cNvSpPr txBox="1"/>
           <p:nvPr/>
         </p:nvSpPr>
         <p:spPr>
           <a:xfrm>
             <a:off x="822960" y="868680"/>
-            <a:ext cx="10515600" cy="457200"/>
+            <a:ext cx="8961120" cy="457200"/>
           </a:xfrm>
           <a:prstGeom prst="rect">
             <a:avLst/>
@@ -3279,7 +3347,7 @@
       </p:sp>
       <p:sp>
         <p:nvSpPr>
-          <p:cNvPr id="6" name="TextBox 5"/>
+          <p:cNvPr id="8" name="TextBox 7"/>
           <p:cNvSpPr txBox="1"/>
           <p:nvPr/>
         </p:nvSpPr>
@@ -3352,7 +3420,7 @@
       </p:sp>
       <p:sp>
         <p:nvSpPr>
-          <p:cNvPr id="7" name="TextBox 6"/>
+          <p:cNvPr id="9" name="TextBox 8"/>
           <p:cNvSpPr txBox="1"/>
           <p:nvPr/>
         </p:nvSpPr>
@@ -4469,8 +4537,8 @@
         </p:nvSpPr>
         <p:spPr>
           <a:xfrm>
-            <a:off x="777240" y="1828800"/>
-            <a:ext cx="10881360" cy="621792"/>
+            <a:off x="777240" y="1536192"/>
+            <a:ext cx="10881360" cy="530352"/>
           </a:xfrm>
           <a:prstGeom prst="rect">
             <a:avLst/>
@@ -4513,8 +4581,8 @@
         </p:nvSpPr>
         <p:spPr>
           <a:xfrm>
-            <a:off x="1005840" y="1828800"/>
-            <a:ext cx="10424160" cy="621792"/>
+            <a:off x="1005840" y="1536192"/>
+            <a:ext cx="10424160" cy="530352"/>
           </a:xfrm>
           <a:prstGeom prst="rect">
             <a:avLst/>
@@ -4529,7 +4597,7 @@
           <a:p>
             <a:pPr algn="ctr"/>
             <a:r>
-              <a:rPr sz="1600" b="0" i="1">
+              <a:rPr sz="1500" b="0" i="1">
                 <a:solidFill>
                   <a:srgbClr val="F4F0E9"/>
                 </a:solidFill>
@@ -4548,8 +4616,8 @@
         </p:nvSpPr>
         <p:spPr>
           <a:xfrm>
-            <a:off x="777240" y="2670048"/>
-            <a:ext cx="5349240" cy="502920"/>
+            <a:off x="777240" y="2194560"/>
+            <a:ext cx="10881360" cy="347472"/>
           </a:xfrm>
           <a:prstGeom prst="rect">
             <a:avLst/>
@@ -4592,8 +4660,8 @@
         </p:nvSpPr>
         <p:spPr>
           <a:xfrm>
-            <a:off x="777240" y="2670048"/>
-            <a:ext cx="5349240" cy="502920"/>
+            <a:off x="960120" y="2194560"/>
+            <a:ext cx="10515600" cy="347472"/>
           </a:xfrm>
           <a:prstGeom prst="rect">
             <a:avLst/>
@@ -4606,29 +4674,58 @@
           </a:bodyPr>
           <a:lstStyle/>
           <a:p>
-            <a:pPr algn="ctr"/>
-            <a:r>
-              <a:rPr sz="1500" b="1" i="0">
+            <a:pPr algn="l"/>
+            <a:r>
+              <a:rPr sz="1300" b="1" i="0">
                 <a:solidFill>
                   <a:srgbClr val="FFFFFF"/>
                 </a:solidFill>
                 <a:latin typeface="Calibri"/>
               </a:rPr>
-              <a:t>Bloque I · Realeza y poder</a:t>
-            </a:r>
-          </a:p>
-        </p:txBody>
-      </p:sp>
-      <p:sp>
-        <p:nvSpPr>
-          <p:cNvPr id="10" name="TextBox 9"/>
+              <a:t>Bloque I · Realeza, poder y organización social</a:t>
+            </a:r>
+          </a:p>
+        </p:txBody>
+      </p:sp>
+      <p:pic>
+        <p:nvPicPr>
+          <p:cNvPr id="10" name="Picture 9" descr="oba.jpeg"/>
+          <p:cNvPicPr>
+            <a:picLocks noChangeAspect="1"/>
+          </p:cNvPicPr>
+          <p:nvPr/>
+        </p:nvPicPr>
+        <p:blipFill>
+          <a:blip r:embed="rId2"/>
+          <a:stretch>
+            <a:fillRect/>
+          </a:stretch>
+        </p:blipFill>
+        <p:spPr>
+          <a:xfrm>
+            <a:off x="1427479" y="2596896"/>
+            <a:ext cx="1406144" cy="1353312"/>
+          </a:xfrm>
+          <a:prstGeom prst="rect">
+            <a:avLst/>
+          </a:prstGeom>
+          <a:ln w="9525">
+            <a:solidFill>
+              <a:srgbClr val="C08A3E"/>
+            </a:solidFill>
+          </a:ln>
+        </p:spPr>
+      </p:pic>
+      <p:sp>
+        <p:nvSpPr>
+          <p:cNvPr id="11" name="TextBox 10"/>
           <p:cNvSpPr txBox="1"/>
           <p:nvPr/>
         </p:nvSpPr>
         <p:spPr>
           <a:xfrm>
-            <a:off x="960120" y="3310128"/>
-            <a:ext cx="5029200" cy="2560320"/>
+            <a:off x="827531" y="3968496"/>
+            <a:ext cx="2606040" cy="292608"/>
           </a:xfrm>
           <a:prstGeom prst="rect">
             <a:avLst/>
@@ -4636,106 +4733,242 @@
           <a:noFill/>
         </p:spPr>
         <p:txBody>
-          <a:bodyPr wrap="square" lIns="0" rIns="0" tIns="0" bIns="0">
+          <a:bodyPr wrap="square" anchor="t" lIns="0" rIns="0" tIns="0" bIns="0">
             <a:spAutoFit/>
           </a:bodyPr>
           <a:lstStyle/>
           <a:p>
-            <a:pPr>
+            <a:pPr algn="ctr">
               <a:lnSpc>
-                <a:spcPct val="105000"/>
+                <a:spcPct val="95000"/>
               </a:lnSpc>
-              <a:spcAft>
-                <a:spcPts val="1200"/>
-              </a:spcAft>
             </a:pPr>
             <a:r>
-              <a:rPr sz="1350" b="1">
-                <a:solidFill>
-                  <a:srgbClr val="C08A3E"/>
-                </a:solidFill>
-                <a:latin typeface="Calibri"/>
-              </a:rPr>
-              <a:t>—  </a:t>
-            </a:r>
-            <a:r>
-              <a:rPr sz="1350">
-                <a:solidFill>
-                  <a:srgbClr val="2A2724"/>
-                </a:solidFill>
-                <a:latin typeface="Calibri"/>
-              </a:rPr>
-              <a:t>Cabezas de oba (Reino de Benín) y de oni (Reino de Ife), Nigeria.</a:t>
-            </a:r>
-          </a:p>
-          <a:p>
-            <a:pPr>
+              <a:rPr sz="950" b="0" i="1">
+                <a:solidFill>
+                  <a:srgbClr val="6B645C"/>
+                </a:solidFill>
+                <a:latin typeface="Calibri"/>
+              </a:rPr>
+              <a:t>Cabeza de oba · Benín</a:t>
+            </a:r>
+          </a:p>
+        </p:txBody>
+      </p:sp>
+      <p:pic>
+        <p:nvPicPr>
+          <p:cNvPr id="12" name="Picture 11" descr="oni.jpeg"/>
+          <p:cNvPicPr>
+            <a:picLocks noChangeAspect="1"/>
+          </p:cNvPicPr>
+          <p:nvPr/>
+        </p:nvPicPr>
+        <p:blipFill>
+          <a:blip r:embed="rId3"/>
+          <a:stretch>
+            <a:fillRect/>
+          </a:stretch>
+        </p:blipFill>
+        <p:spPr>
+          <a:xfrm>
+            <a:off x="4180446" y="2596896"/>
+            <a:ext cx="1350035" cy="1353312"/>
+          </a:xfrm>
+          <a:prstGeom prst="rect">
+            <a:avLst/>
+          </a:prstGeom>
+          <a:ln w="9525">
+            <a:solidFill>
+              <a:srgbClr val="C08A3E"/>
+            </a:solidFill>
+          </a:ln>
+        </p:spPr>
+      </p:pic>
+      <p:sp>
+        <p:nvSpPr>
+          <p:cNvPr id="13" name="TextBox 12"/>
+          <p:cNvSpPr txBox="1"/>
+          <p:nvPr/>
+        </p:nvSpPr>
+        <p:spPr>
+          <a:xfrm>
+            <a:off x="3552444" y="3968496"/>
+            <a:ext cx="2606040" cy="292608"/>
+          </a:xfrm>
+          <a:prstGeom prst="rect">
+            <a:avLst/>
+          </a:prstGeom>
+          <a:noFill/>
+        </p:spPr>
+        <p:txBody>
+          <a:bodyPr wrap="square" anchor="t" lIns="0" rIns="0" tIns="0" bIns="0">
+            <a:spAutoFit/>
+          </a:bodyPr>
+          <a:lstStyle/>
+          <a:p>
+            <a:pPr algn="ctr">
               <a:lnSpc>
-                <a:spcPct val="105000"/>
+                <a:spcPct val="95000"/>
               </a:lnSpc>
-              <a:spcAft>
-                <a:spcPts val="1200"/>
-              </a:spcAft>
             </a:pPr>
             <a:r>
-              <a:rPr sz="1350" b="1">
-                <a:solidFill>
-                  <a:srgbClr val="C08A3E"/>
-                </a:solidFill>
-                <a:latin typeface="Calibri"/>
-              </a:rPr>
-              <a:t>—  </a:t>
-            </a:r>
-            <a:r>
-              <a:rPr sz="1350">
-                <a:solidFill>
-                  <a:srgbClr val="2A2724"/>
-                </a:solidFill>
-                <a:latin typeface="Calibri"/>
-              </a:rPr>
-              <a:t>Guerreros y leopardos de bronce de Benín (British Museum).</a:t>
-            </a:r>
-          </a:p>
-          <a:p>
-            <a:pPr>
+              <a:rPr sz="950" b="0" i="1">
+                <a:solidFill>
+                  <a:srgbClr val="6B645C"/>
+                </a:solidFill>
+                <a:latin typeface="Calibri"/>
+              </a:rPr>
+              <a:t>Cabeza de oni · Ife</a:t>
+            </a:r>
+          </a:p>
+        </p:txBody>
+      </p:sp>
+      <p:pic>
+        <p:nvPicPr>
+          <p:cNvPr id="14" name="Picture 13" descr="guerreros.jpeg"/>
+          <p:cNvPicPr>
+            <a:picLocks noChangeAspect="1"/>
+          </p:cNvPicPr>
+          <p:nvPr/>
+        </p:nvPicPr>
+        <p:blipFill>
+          <a:blip r:embed="rId4"/>
+          <a:stretch>
+            <a:fillRect/>
+          </a:stretch>
+        </p:blipFill>
+        <p:spPr>
+          <a:xfrm>
+            <a:off x="6903719" y="2596896"/>
+            <a:ext cx="1353312" cy="1353312"/>
+          </a:xfrm>
+          <a:prstGeom prst="rect">
+            <a:avLst/>
+          </a:prstGeom>
+          <a:ln w="9525">
+            <a:solidFill>
+              <a:srgbClr val="C08A3E"/>
+            </a:solidFill>
+          </a:ln>
+        </p:spPr>
+      </p:pic>
+      <p:sp>
+        <p:nvSpPr>
+          <p:cNvPr id="15" name="TextBox 14"/>
+          <p:cNvSpPr txBox="1"/>
+          <p:nvPr/>
+        </p:nvSpPr>
+        <p:spPr>
+          <a:xfrm>
+            <a:off x="6277355" y="3968496"/>
+            <a:ext cx="2606040" cy="292608"/>
+          </a:xfrm>
+          <a:prstGeom prst="rect">
+            <a:avLst/>
+          </a:prstGeom>
+          <a:noFill/>
+        </p:spPr>
+        <p:txBody>
+          <a:bodyPr wrap="square" anchor="t" lIns="0" rIns="0" tIns="0" bIns="0">
+            <a:spAutoFit/>
+          </a:bodyPr>
+          <a:lstStyle/>
+          <a:p>
+            <a:pPr algn="ctr">
               <a:lnSpc>
-                <a:spcPct val="105000"/>
+                <a:spcPct val="95000"/>
               </a:lnSpc>
-              <a:spcAft>
-                <a:spcPts val="1200"/>
-              </a:spcAft>
             </a:pPr>
             <a:r>
-              <a:rPr sz="1350" b="1">
-                <a:solidFill>
-                  <a:srgbClr val="C08A3E"/>
-                </a:solidFill>
-                <a:latin typeface="Calibri"/>
-              </a:rPr>
-              <a:t>—  </a:t>
-            </a:r>
-            <a:r>
-              <a:rPr sz="1350">
-                <a:solidFill>
-                  <a:srgbClr val="2A2724"/>
-                </a:solidFill>
-                <a:latin typeface="Calibri"/>
-              </a:rPr>
-              <a:t>Montaje rítmico y fundidos: ¿colonizó Francia un pueblo «sin cultura»?</a:t>
-            </a:r>
-          </a:p>
-        </p:txBody>
-      </p:sp>
-      <p:sp>
-        <p:nvSpPr>
-          <p:cNvPr id="11" name="Rectangle 10"/>
+              <a:rPr sz="950" b="0" i="1">
+                <a:solidFill>
+                  <a:srgbClr val="6B645C"/>
+                </a:solidFill>
+                <a:latin typeface="Calibri"/>
+              </a:rPr>
+              <a:t>Guerreros de Benín</a:t>
+            </a:r>
+          </a:p>
+        </p:txBody>
+      </p:sp>
+      <p:pic>
+        <p:nvPicPr>
+          <p:cNvPr id="16" name="Picture 15" descr="leopardos.jpeg"/>
+          <p:cNvPicPr>
+            <a:picLocks noChangeAspect="1"/>
+          </p:cNvPicPr>
+          <p:nvPr/>
+        </p:nvPicPr>
+        <p:blipFill>
+          <a:blip r:embed="rId5"/>
+          <a:stretch>
+            <a:fillRect/>
+          </a:stretch>
+        </p:blipFill>
+        <p:spPr>
+          <a:xfrm>
+            <a:off x="9002267" y="2642027"/>
+            <a:ext cx="2606040" cy="1263050"/>
+          </a:xfrm>
+          <a:prstGeom prst="rect">
+            <a:avLst/>
+          </a:prstGeom>
+          <a:ln w="9525">
+            <a:solidFill>
+              <a:srgbClr val="C08A3E"/>
+            </a:solidFill>
+          </a:ln>
+        </p:spPr>
+      </p:pic>
+      <p:sp>
+        <p:nvSpPr>
+          <p:cNvPr id="17" name="TextBox 16"/>
+          <p:cNvSpPr txBox="1"/>
+          <p:nvPr/>
+        </p:nvSpPr>
+        <p:spPr>
+          <a:xfrm>
+            <a:off x="9002267" y="3968496"/>
+            <a:ext cx="2606040" cy="292608"/>
+          </a:xfrm>
+          <a:prstGeom prst="rect">
+            <a:avLst/>
+          </a:prstGeom>
+          <a:noFill/>
+        </p:spPr>
+        <p:txBody>
+          <a:bodyPr wrap="square" anchor="t" lIns="0" rIns="0" tIns="0" bIns="0">
+            <a:spAutoFit/>
+          </a:bodyPr>
+          <a:lstStyle/>
+          <a:p>
+            <a:pPr algn="ctr">
+              <a:lnSpc>
+                <a:spcPct val="95000"/>
+              </a:lnSpc>
+            </a:pPr>
+            <a:r>
+              <a:rPr sz="950" b="0" i="1">
+                <a:solidFill>
+                  <a:srgbClr val="6B645C"/>
+                </a:solidFill>
+                <a:latin typeface="Calibri"/>
+              </a:rPr>
+              <a:t>Leopardos · Benín</a:t>
+            </a:r>
+          </a:p>
+        </p:txBody>
+      </p:sp>
+      <p:sp>
+        <p:nvSpPr>
+          <p:cNvPr id="18" name="Rectangle 17"/>
           <p:cNvSpPr/>
           <p:nvPr/>
         </p:nvSpPr>
         <p:spPr>
           <a:xfrm>
-            <a:off x="6400800" y="2670048"/>
-            <a:ext cx="5257800" cy="502920"/>
+            <a:off x="777240" y="4242816"/>
+            <a:ext cx="10881360" cy="347472"/>
           </a:xfrm>
           <a:prstGeom prst="rect">
             <a:avLst/>
@@ -4772,14 +5005,14 @@
       </p:sp>
       <p:sp>
         <p:nvSpPr>
-          <p:cNvPr id="12" name="TextBox 11"/>
+          <p:cNvPr id="19" name="TextBox 18"/>
           <p:cNvSpPr txBox="1"/>
           <p:nvPr/>
         </p:nvSpPr>
         <p:spPr>
           <a:xfrm>
-            <a:off x="6400800" y="2670048"/>
-            <a:ext cx="5257800" cy="502920"/>
+            <a:off x="960120" y="4242816"/>
+            <a:ext cx="10515600" cy="347472"/>
           </a:xfrm>
           <a:prstGeom prst="rect">
             <a:avLst/>
@@ -4792,29 +5025,58 @@
           </a:bodyPr>
           <a:lstStyle/>
           <a:p>
-            <a:pPr algn="ctr"/>
-            <a:r>
-              <a:rPr sz="1500" b="1" i="0">
+            <a:pPr algn="l"/>
+            <a:r>
+              <a:rPr sz="1300" b="1" i="0">
                 <a:solidFill>
                   <a:srgbClr val="FFFFFF"/>
                 </a:solidFill>
                 <a:latin typeface="Calibri"/>
               </a:rPr>
-              <a:t>Bloque II · Culto y ritual</a:t>
-            </a:r>
-          </a:p>
-        </p:txBody>
-      </p:sp>
-      <p:sp>
-        <p:nvSpPr>
-          <p:cNvPr id="13" name="TextBox 12"/>
+              <a:t>Bloque II · Culto, ritual y ancestros</a:t>
+            </a:r>
+          </a:p>
+        </p:txBody>
+      </p:sp>
+      <p:pic>
+        <p:nvPicPr>
+          <p:cNvPr id="20" name="Picture 19" descr="kota.jpeg"/>
+          <p:cNvPicPr>
+            <a:picLocks noChangeAspect="1"/>
+          </p:cNvPicPr>
+          <p:nvPr/>
+        </p:nvPicPr>
+        <p:blipFill>
+          <a:blip r:embed="rId6"/>
+          <a:stretch>
+            <a:fillRect/>
+          </a:stretch>
+        </p:blipFill>
+        <p:spPr>
+          <a:xfrm>
+            <a:off x="1602688" y="4645152"/>
+            <a:ext cx="1055725" cy="1353312"/>
+          </a:xfrm>
+          <a:prstGeom prst="rect">
+            <a:avLst/>
+          </a:prstGeom>
+          <a:ln w="9525">
+            <a:solidFill>
+              <a:srgbClr val="C08A3E"/>
+            </a:solidFill>
+          </a:ln>
+        </p:spPr>
+      </p:pic>
+      <p:sp>
+        <p:nvSpPr>
+          <p:cNvPr id="21" name="TextBox 20"/>
           <p:cNvSpPr txBox="1"/>
           <p:nvPr/>
         </p:nvSpPr>
         <p:spPr>
           <a:xfrm>
-            <a:off x="6583680" y="3310128"/>
-            <a:ext cx="4937760" cy="2560320"/>
+            <a:off x="827531" y="6016752"/>
+            <a:ext cx="2606040" cy="292608"/>
           </a:xfrm>
           <a:prstGeom prst="rect">
             <a:avLst/>
@@ -4822,99 +5084,235 @@
           <a:noFill/>
         </p:spPr>
         <p:txBody>
-          <a:bodyPr wrap="square" lIns="0" rIns="0" tIns="0" bIns="0">
+          <a:bodyPr wrap="square" anchor="t" lIns="0" rIns="0" tIns="0" bIns="0">
             <a:spAutoFit/>
           </a:bodyPr>
           <a:lstStyle/>
           <a:p>
-            <a:pPr>
+            <a:pPr algn="ctr">
               <a:lnSpc>
-                <a:spcPct val="105000"/>
+                <a:spcPct val="95000"/>
               </a:lnSpc>
-              <a:spcAft>
-                <a:spcPts val="1200"/>
-              </a:spcAft>
             </a:pPr>
             <a:r>
-              <a:rPr sz="1350" b="1">
-                <a:solidFill>
-                  <a:srgbClr val="C08A3E"/>
-                </a:solidFill>
-                <a:latin typeface="Calibri"/>
-              </a:rPr>
-              <a:t>—  </a:t>
-            </a:r>
-            <a:r>
-              <a:rPr sz="1350">
-                <a:solidFill>
-                  <a:srgbClr val="2A2724"/>
-                </a:solidFill>
-                <a:latin typeface="Calibri"/>
-              </a:rPr>
-              <a:t>Relicarios Kota (Gabón); tableros de adivinación Ifá, Yoruba (Nigeria).</a:t>
-            </a:r>
-          </a:p>
-          <a:p>
-            <a:pPr>
+              <a:rPr sz="950" b="0" i="1">
+                <a:solidFill>
+                  <a:srgbClr val="6B645C"/>
+                </a:solidFill>
+                <a:latin typeface="Calibri"/>
+              </a:rPr>
+              <a:t>Relicario Kota · Gabón</a:t>
+            </a:r>
+          </a:p>
+        </p:txBody>
+      </p:sp>
+      <p:pic>
+        <p:nvPicPr>
+          <p:cNvPr id="22" name="Picture 21" descr="ifa.jpeg"/>
+          <p:cNvPicPr>
+            <a:picLocks noChangeAspect="1"/>
+          </p:cNvPicPr>
+          <p:nvPr/>
+        </p:nvPicPr>
+        <p:blipFill>
+          <a:blip r:embed="rId7"/>
+          <a:stretch>
+            <a:fillRect/>
+          </a:stretch>
+        </p:blipFill>
+        <p:spPr>
+          <a:xfrm>
+            <a:off x="3962473" y="4645152"/>
+            <a:ext cx="1785981" cy="1353312"/>
+          </a:xfrm>
+          <a:prstGeom prst="rect">
+            <a:avLst/>
+          </a:prstGeom>
+          <a:ln w="9525">
+            <a:solidFill>
+              <a:srgbClr val="C08A3E"/>
+            </a:solidFill>
+          </a:ln>
+        </p:spPr>
+      </p:pic>
+      <p:sp>
+        <p:nvSpPr>
+          <p:cNvPr id="23" name="TextBox 22"/>
+          <p:cNvSpPr txBox="1"/>
+          <p:nvPr/>
+        </p:nvSpPr>
+        <p:spPr>
+          <a:xfrm>
+            <a:off x="3552444" y="6016752"/>
+            <a:ext cx="2606040" cy="292608"/>
+          </a:xfrm>
+          <a:prstGeom prst="rect">
+            <a:avLst/>
+          </a:prstGeom>
+          <a:noFill/>
+        </p:spPr>
+        <p:txBody>
+          <a:bodyPr wrap="square" anchor="t" lIns="0" rIns="0" tIns="0" bIns="0">
+            <a:spAutoFit/>
+          </a:bodyPr>
+          <a:lstStyle/>
+          <a:p>
+            <a:pPr algn="ctr">
               <a:lnSpc>
-                <a:spcPct val="105000"/>
+                <a:spcPct val="95000"/>
               </a:lnSpc>
-              <a:spcAft>
-                <a:spcPts val="1200"/>
-              </a:spcAft>
             </a:pPr>
             <a:r>
-              <a:rPr sz="1350" b="1">
-                <a:solidFill>
-                  <a:srgbClr val="C08A3E"/>
-                </a:solidFill>
-                <a:latin typeface="Calibri"/>
-              </a:rPr>
-              <a:t>—  </a:t>
-            </a:r>
-            <a:r>
-              <a:rPr sz="1350">
-                <a:solidFill>
-                  <a:srgbClr val="2A2724"/>
-                </a:solidFill>
-                <a:latin typeface="Calibri"/>
-              </a:rPr>
-              <a:t>Reposacabezas Pende (R. D. del Congo); máscaras Dan (Costa de Marfil).</a:t>
-            </a:r>
-          </a:p>
-          <a:p>
-            <a:pPr>
+              <a:rPr sz="950" b="0" i="1">
+                <a:solidFill>
+                  <a:srgbClr val="6B645C"/>
+                </a:solidFill>
+                <a:latin typeface="Calibri"/>
+              </a:rPr>
+              <a:t>Tablero Ifá · Yoruba</a:t>
+            </a:r>
+          </a:p>
+        </p:txBody>
+      </p:sp>
+      <p:pic>
+        <p:nvPicPr>
+          <p:cNvPr id="24" name="Picture 23" descr="pende.jpeg"/>
+          <p:cNvPicPr>
+            <a:picLocks noChangeAspect="1"/>
+          </p:cNvPicPr>
+          <p:nvPr/>
+        </p:nvPicPr>
+        <p:blipFill>
+          <a:blip r:embed="rId8"/>
+          <a:stretch>
+            <a:fillRect/>
+          </a:stretch>
+        </p:blipFill>
+        <p:spPr>
+          <a:xfrm>
+            <a:off x="6684182" y="4645152"/>
+            <a:ext cx="1792386" cy="1353312"/>
+          </a:xfrm>
+          <a:prstGeom prst="rect">
+            <a:avLst/>
+          </a:prstGeom>
+          <a:ln w="9525">
+            <a:solidFill>
+              <a:srgbClr val="C08A3E"/>
+            </a:solidFill>
+          </a:ln>
+        </p:spPr>
+      </p:pic>
+      <p:sp>
+        <p:nvSpPr>
+          <p:cNvPr id="25" name="TextBox 24"/>
+          <p:cNvSpPr txBox="1"/>
+          <p:nvPr/>
+        </p:nvSpPr>
+        <p:spPr>
+          <a:xfrm>
+            <a:off x="6277355" y="6016752"/>
+            <a:ext cx="2606040" cy="292608"/>
+          </a:xfrm>
+          <a:prstGeom prst="rect">
+            <a:avLst/>
+          </a:prstGeom>
+          <a:noFill/>
+        </p:spPr>
+        <p:txBody>
+          <a:bodyPr wrap="square" anchor="t" lIns="0" rIns="0" tIns="0" bIns="0">
+            <a:spAutoFit/>
+          </a:bodyPr>
+          <a:lstStyle/>
+          <a:p>
+            <a:pPr algn="ctr">
               <a:lnSpc>
-                <a:spcPct val="105000"/>
+                <a:spcPct val="95000"/>
               </a:lnSpc>
-              <a:spcAft>
-                <a:spcPts val="1200"/>
-              </a:spcAft>
             </a:pPr>
             <a:r>
-              <a:rPr sz="1350" b="1">
-                <a:solidFill>
-                  <a:srgbClr val="C08A3E"/>
-                </a:solidFill>
-                <a:latin typeface="Calibri"/>
-              </a:rPr>
-              <a:t>—  </a:t>
-            </a:r>
-            <a:r>
-              <a:rPr sz="1350">
-                <a:solidFill>
-                  <a:srgbClr val="2A2724"/>
-                </a:solidFill>
-                <a:latin typeface="Calibri"/>
-              </a:rPr>
-              <a:t>Culto animista y a los ancestros; piezas deliberadamente sin contexto.</a:t>
-            </a:r>
-          </a:p>
-        </p:txBody>
-      </p:sp>
-      <p:sp>
-        <p:nvSpPr>
-          <p:cNvPr id="14" name="Rectangle 13"/>
+              <a:rPr sz="950" b="0" i="1">
+                <a:solidFill>
+                  <a:srgbClr val="6B645C"/>
+                </a:solidFill>
+                <a:latin typeface="Calibri"/>
+              </a:rPr>
+              <a:t>Reposacabezas Pende</a:t>
+            </a:r>
+          </a:p>
+        </p:txBody>
+      </p:sp>
+      <p:pic>
+        <p:nvPicPr>
+          <p:cNvPr id="26" name="Picture 25" descr="dan.jpeg"/>
+          <p:cNvPicPr>
+            <a:picLocks noChangeAspect="1"/>
+          </p:cNvPicPr>
+          <p:nvPr/>
+        </p:nvPicPr>
+        <p:blipFill>
+          <a:blip r:embed="rId9"/>
+          <a:stretch>
+            <a:fillRect/>
+          </a:stretch>
+        </p:blipFill>
+        <p:spPr>
+          <a:xfrm>
+            <a:off x="9895313" y="4645152"/>
+            <a:ext cx="819947" cy="1353312"/>
+          </a:xfrm>
+          <a:prstGeom prst="rect">
+            <a:avLst/>
+          </a:prstGeom>
+          <a:ln w="9525">
+            <a:solidFill>
+              <a:srgbClr val="C08A3E"/>
+            </a:solidFill>
+          </a:ln>
+        </p:spPr>
+      </p:pic>
+      <p:sp>
+        <p:nvSpPr>
+          <p:cNvPr id="27" name="TextBox 26"/>
+          <p:cNvSpPr txBox="1"/>
+          <p:nvPr/>
+        </p:nvSpPr>
+        <p:spPr>
+          <a:xfrm>
+            <a:off x="9002267" y="6016752"/>
+            <a:ext cx="2606040" cy="292608"/>
+          </a:xfrm>
+          <a:prstGeom prst="rect">
+            <a:avLst/>
+          </a:prstGeom>
+          <a:noFill/>
+        </p:spPr>
+        <p:txBody>
+          <a:bodyPr wrap="square" anchor="t" lIns="0" rIns="0" tIns="0" bIns="0">
+            <a:spAutoFit/>
+          </a:bodyPr>
+          <a:lstStyle/>
+          <a:p>
+            <a:pPr algn="ctr">
+              <a:lnSpc>
+                <a:spcPct val="95000"/>
+              </a:lnSpc>
+            </a:pPr>
+            <a:r>
+              <a:rPr sz="950" b="0" i="1">
+                <a:solidFill>
+                  <a:srgbClr val="6B645C"/>
+                </a:solidFill>
+                <a:latin typeface="Calibri"/>
+              </a:rPr>
+              <a:t>Máscara Dan · C. de Marfil</a:t>
+            </a:r>
+          </a:p>
+        </p:txBody>
+      </p:sp>
+      <p:sp>
+        <p:nvSpPr>
+          <p:cNvPr id="28" name="Rectangle 27"/>
           <p:cNvSpPr/>
           <p:nvPr/>
         </p:nvSpPr>
@@ -4958,7 +5356,7 @@
       </p:sp>
       <p:sp>
         <p:nvSpPr>
-          <p:cNvPr id="15" name="TextBox 14"/>
+          <p:cNvPr id="29" name="TextBox 28"/>
           <p:cNvSpPr txBox="1"/>
           <p:nvPr/>
         </p:nvSpPr>
@@ -4993,7 +5391,7 @@
       </p:sp>
       <p:sp>
         <p:nvSpPr>
-          <p:cNvPr id="16" name="TextBox 15"/>
+          <p:cNvPr id="30" name="TextBox 29"/>
           <p:cNvSpPr txBox="1"/>
           <p:nvPr/>
         </p:nvSpPr>
@@ -12991,7 +13389,7 @@
         <p:spPr>
           <a:xfrm>
             <a:off x="978408" y="2487168"/>
-            <a:ext cx="3118104" cy="3291840"/>
+            <a:ext cx="3118104" cy="1554480"/>
           </a:xfrm>
           <a:prstGeom prst="rect">
             <a:avLst/>
@@ -13525,9 +13923,77 @@
           </a:p>
         </p:txBody>
       </p:sp>
-      <p:sp>
-        <p:nvSpPr>
-          <p:cNvPr id="18" name="Rectangle 17"/>
+      <p:pic>
+        <p:nvPicPr>
+          <p:cNvPr id="18" name="Picture 17" descr="berlin.jpeg"/>
+          <p:cNvPicPr>
+            <a:picLocks noChangeAspect="1"/>
+          </p:cNvPicPr>
+          <p:nvPr/>
+        </p:nvPicPr>
+        <p:blipFill>
+          <a:blip r:embed="rId2"/>
+          <a:stretch>
+            <a:fillRect/>
+          </a:stretch>
+        </p:blipFill>
+        <p:spPr>
+          <a:xfrm>
+            <a:off x="1651572" y="3931920"/>
+            <a:ext cx="1762631" cy="1627632"/>
+          </a:xfrm>
+          <a:prstGeom prst="rect">
+            <a:avLst/>
+          </a:prstGeom>
+          <a:ln w="9525">
+            <a:solidFill>
+              <a:srgbClr val="C08A3E"/>
+            </a:solidFill>
+          </a:ln>
+        </p:spPr>
+      </p:pic>
+      <p:sp>
+        <p:nvSpPr>
+          <p:cNvPr id="19" name="TextBox 18"/>
+          <p:cNvSpPr txBox="1"/>
+          <p:nvPr/>
+        </p:nvSpPr>
+        <p:spPr>
+          <a:xfrm>
+            <a:off x="886968" y="5614416"/>
+            <a:ext cx="3291840" cy="292608"/>
+          </a:xfrm>
+          <a:prstGeom prst="rect">
+            <a:avLst/>
+          </a:prstGeom>
+          <a:noFill/>
+        </p:spPr>
+        <p:txBody>
+          <a:bodyPr wrap="square" anchor="t" lIns="0" rIns="0" tIns="0" bIns="0">
+            <a:spAutoFit/>
+          </a:bodyPr>
+          <a:lstStyle/>
+          <a:p>
+            <a:pPr algn="ctr">
+              <a:lnSpc>
+                <a:spcPct val="95000"/>
+              </a:lnSpc>
+            </a:pPr>
+            <a:r>
+              <a:rPr sz="950" b="0" i="1">
+                <a:solidFill>
+                  <a:srgbClr val="6B645C"/>
+                </a:solidFill>
+                <a:latin typeface="Calibri"/>
+              </a:rPr>
+              <a:t>Caricatura del reparto de África (L'Illustration, 1885)</a:t>
+            </a:r>
+          </a:p>
+        </p:txBody>
+      </p:sp>
+      <p:sp>
+        <p:nvSpPr>
+          <p:cNvPr id="20" name="Rectangle 19"/>
           <p:cNvSpPr/>
           <p:nvPr/>
         </p:nvSpPr>
@@ -13571,7 +14037,7 @@
       </p:sp>
       <p:sp>
         <p:nvSpPr>
-          <p:cNvPr id="19" name="TextBox 18"/>
+          <p:cNvPr id="21" name="TextBox 20"/>
           <p:cNvSpPr txBox="1"/>
           <p:nvPr/>
         </p:nvSpPr>
@@ -13606,7 +14072,7 @@
       </p:sp>
       <p:sp>
         <p:nvSpPr>
-          <p:cNvPr id="20" name="TextBox 19"/>
+          <p:cNvPr id="22" name="TextBox 21"/>
           <p:cNvSpPr txBox="1"/>
           <p:nvPr/>
         </p:nvSpPr>

</xml_diff>